<commit_message>
docs: Update About page and presentation materials for clarity and accuracy
</commit_message>
<xml_diff>
--- a/presentation/Final_Presentation.pptx
+++ b/presentation/Final_Presentation.pptx
@@ -3244,7 +3244,7 @@
                   <a:srgbClr val="4FB3BF"/>
                 </a:solidFill>
               </a:rPr>
-              <a:t>Final Project Presentation</a:t>
+              <a:t>Hybrid ResNet-50 + BiLSTM · FaceForensics++</a:t>
             </a:r>
           </a:p>
         </p:txBody>
@@ -4241,7 +4241,7 @@
                   <a:srgbClr val="1B1F3B"/>
                 </a:solidFill>
               </a:rPr>
-              <a:t>• Designed as a course demo, not for forensic use.</a:t>
+              <a:t>• Research demo only — not a forensic-grade detector.</a:t>
             </a:r>
           </a:p>
         </p:txBody>

</xml_diff>